<commit_message>
docs(pitch): apply independent review fixes
Demo not called live, sponsor line shortened, timeframes separated,
competitor wording softened, market source line corrected, DiligenceVault
named as closest comparable.

Co-Authored-By: Claude Opus 5.5 <noreply@anthropic.com>
</commit_message>
<xml_diff>
--- a/docs/presentation/second-look-pitch.pptx
+++ b/docs/presentation/second-look-pitch.pptx
@@ -588,7 +588,7 @@
           </a:p>
           <a:p>
             <a:r>
-              <a:t>Investors selling a fund stake decide from a quarterly report that’s months old, while the companies move and the buyer revises terms. LPs sold about 125 billion dollars of fund stakes last year, at around 87 cents on the dollar, so one point of price is worth about 1.4 billion a year. And about 40 percent of these sellers are first-timers.</a:t>
+              <a:t>Investors selling a fund stake decide from a quarterly report that’s months old, while the companies move and the buyer revises terms. LPs sold about 125 billion dollars of fund stakes last year, and this year they’re averaging around 87 cents on the dollar, so one point of price is worth roughly 1.4 billion a year. And about 40 percent of these sellers are first-timers.</a:t>
             </a:r>
           </a:p>
           <a:p/>
@@ -745,12 +745,12 @@
           <a:lstStyle/>
           <a:p>
             <a:r>
-              <a:t>[0:50–1:50] LIVE DEMO (about 60 seconds; click as you speak)</a:t>
-            </a:r>
-          </a:p>
-          <a:p>
-            <a:r>
-              <a:t>The fund and deal are fictional; the game data is real. Someone offers me 700,000 dollars for my gaming-fund stake. I open Tiny Glade: real Steam reviews from before and after the last report, and Akta’s studio profile. Players love it, but that doesn’t tell me who gets the money. So the evidence becomes a question for the manager: Roundtable routes it to a reviewer, Nicrron drafts it, PRISM traces the model call. I share it. As the manager: a 100,000 dollar distribution belongs to this stake. As the investor: 800,000 dollars gross. I approve version one. Now the buyer moves that distribution to themselves. Same 700,000 price, but I get 700,000, and my old approval no longer applies. I reload: the record is still here.</a:t>
+              <a:t>[0:50–1:50] DEMO (about 60 seconds; click as you speak)</a:t>
+            </a:r>
+          </a:p>
+          <a:p>
+            <a:r>
+              <a:t>The fund and deal are fictional; the game data is real. Someone offers me 700,000 dollars for my gaming-fund stake. I open Tiny Glade: real Steam reviews from before and after the last report, and Akta’s studio profile. Roundtable and Nicrron turn that evidence into a question for the manager; PRISM records the trace. I share it. As the manager: a 100,000 dollar distribution belongs to this stake. As the investor: 800,000 dollars gross. I approve version one. Now the buyer moves that distribution to themselves. Same 700,000 price, but I receive 700,000 gross, and my old approval no longer applies. I reload: the record is still here.</a:t>
             </a:r>
           </a:p>
           <a:p/>
@@ -4842,7 +4842,7 @@
                 </a:solidFill>
                 <a:latin typeface="Arial"/>
               </a:rPr>
-              <a:t>Built on periodic GP reports, so still dated at the decision</a:t>
+              <a:t>Mainly built on periodic GP reports, not a specific sale’s terms</a:t>
             </a:r>
           </a:p>
         </p:txBody>
@@ -5037,7 +5037,7 @@
                 </a:solidFill>
                 <a:latin typeface="Arial"/>
               </a:rPr>
-              <a:t>Descriptions based on each vendor’s public positioning; not a hands-on evaluation.</a:t>
+              <a:t>Closest comparable: DiligenceVault (versioned diligence Q&amp;A, approval trails). Descriptions from vendors’ public positioning; not a hands-on evaluation.</a:t>
             </a:r>
           </a:p>
         </p:txBody>
@@ -5094,7 +5094,7 @@
                 </a:solidFill>
                 <a:latin typeface="Arial"/>
               </a:rPr>
-              <a:t>OUR PRODUCT · LIVE DEMO</a:t>
+              <a:t>OUR PRODUCT · DEMO</a:t>
             </a:r>
           </a:p>
         </p:txBody>
@@ -6802,7 +6802,7 @@
                 </a:solidFill>
                 <a:latin typeface="Arial"/>
               </a:rPr>
-              <a:t>Estimates from Second Look market sizing (Oct 24, 2026), built on stated assumptions; pricing based on Jefferies H1 2026 (87% of NAV). Not validated with customers.</a:t>
+              <a:t>Second Look estimates (Oct 24, 2026) from stated assumptions; $75M stake is illustrative, ≈$86M NAV at Jefferies’ H1 2026 87%. $500/team/month is an untested hypothesis.</a:t>
             </a:r>
           </a:p>
         </p:txBody>

</xml_diff>

<commit_message>
docs(pitch): use the defensible closing line
Co-Authored-By: Claude Opus 5.5 <noreply@anthropic.com>
</commit_message>
<xml_diff>
--- a/docs/presentation/second-look-pitch.pptx
+++ b/docs/presentation/second-look-pitch.pptx
@@ -987,7 +987,7 @@
           </a:p>
           <a:p>
             <a:r>
-              <a:t>Investors approve fund sales on outdated information, and terms change under them. Second Look catches both before money is lost. We’re Mat, Ryan, Darren and Stratten. The demo link is on screen.</a:t>
+              <a:t>Investors approve fund sales on outdated information, and terms change under them. Second Look puts the new evidence to the manager and retires an approval the moment the terms change. We’re Mat, Ryan, Darren and Stratten. The demo link is on screen.</a:t>
             </a:r>
           </a:p>
           <a:p/>
@@ -6898,7 +6898,7 @@
                 </a:solidFill>
                 <a:latin typeface="Arial"/>
               </a:rPr>
-              <a:t>Investors approve fund sales on outdated information, and terms change under them. Second Look catches both before money is lost.</a:t>
+              <a:t>Investors approve fund sales on outdated information, and terms change under them. Second Look puts the new evidence to the manager and retires an approval the moment the terms change.</a:t>
             </a:r>
           </a:p>
         </p:txBody>

</xml_diff>